<commit_message>
Emit page numbers as auto-updating slide-number fields in PPTX
Page numbers were static text runs, so Google Slides (and PowerPoint) treated
them as fixed labels that don't renumber when slides are moved or added.

Emit the page-number chrome run as a native <a:fld type="slidenum"> field, which
both apps recognise and renumber live. slidekit's page number already equals the
physical slide position, so the field shows the same value; a non-default
start_at sets the deck-wide firstSlideNum so the field still matches. The skipped
title slide carries no field. PDF/HTML keep the static number (those formats have
no live fields).

Add ResolvedNode.field (emit-only, not serialized — no golden churn), set it on
the page-number node, convert the run in the PPTX emitter, and regenerate both
committed deck exports. Tests cover the field emission, the skipped title slide,
and the start_at origin.

Claude-Session: https://claude.ai/code/session_01ThK5xFevzMSgSSoMhVCn6y
</commit_message>
<xml_diff>
--- a/examples/pptx/claude-code-for-data-scientists.pptx
+++ b/examples/pptx/claude-code-for-data-scientists.pptx
@@ -3393,7 +3393,7 @@
           <a:lstStyle/>
           <a:p>
             <a:pPr algn="l"/>
-            <a:r>
+            <a:fld id="{4B0E1F8A-6C1D-4E2A-9F3B-7A5C8D2E1F60}" type="slidenum">
               <a:rPr sz="1600" b="0" i="0">
                 <a:solidFill>
                   <a:srgbClr val="8A8A9A"/>
@@ -3401,7 +3401,7 @@
                 <a:latin typeface="Arial"/>
               </a:rPr>
               <a:t>10</a:t>
-            </a:r>
+            </a:fld>
           </a:p>
         </p:txBody>
       </p:sp>
@@ -3665,7 +3665,7 @@
           <a:lstStyle/>
           <a:p>
             <a:pPr algn="l"/>
-            <a:r>
+            <a:fld id="{4B0E1F8A-6C1D-4E2A-9F3B-7A5C8D2E1F60}" type="slidenum">
               <a:rPr sz="1600" b="0" i="0">
                 <a:solidFill>
                   <a:srgbClr val="8A8A9A"/>
@@ -3673,7 +3673,7 @@
                 <a:latin typeface="Arial"/>
               </a:rPr>
               <a:t>11</a:t>
-            </a:r>
+            </a:fld>
           </a:p>
         </p:txBody>
       </p:sp>
@@ -3840,7 +3840,7 @@
           <a:lstStyle/>
           <a:p>
             <a:pPr algn="l"/>
-            <a:r>
+            <a:fld id="{4B0E1F8A-6C1D-4E2A-9F3B-7A5C8D2E1F60}" type="slidenum">
               <a:rPr sz="1600" b="0" i="0">
                 <a:solidFill>
                   <a:srgbClr val="8A8A9A"/>
@@ -3848,7 +3848,7 @@
                 <a:latin typeface="Arial"/>
               </a:rPr>
               <a:t>12</a:t>
-            </a:r>
+            </a:fld>
           </a:p>
         </p:txBody>
       </p:sp>
@@ -4041,7 +4041,7 @@
           <a:lstStyle/>
           <a:p>
             <a:pPr algn="l"/>
-            <a:r>
+            <a:fld id="{4B0E1F8A-6C1D-4E2A-9F3B-7A5C8D2E1F60}" type="slidenum">
               <a:rPr sz="1600" b="0" i="0">
                 <a:solidFill>
                   <a:srgbClr val="8A8A9A"/>
@@ -4049,7 +4049,7 @@
                 <a:latin typeface="Arial"/>
               </a:rPr>
               <a:t>13</a:t>
-            </a:r>
+            </a:fld>
           </a:p>
         </p:txBody>
       </p:sp>
@@ -4646,7 +4646,7 @@
           <a:lstStyle/>
           <a:p>
             <a:pPr algn="l"/>
-            <a:r>
+            <a:fld id="{4B0E1F8A-6C1D-4E2A-9F3B-7A5C8D2E1F60}" type="slidenum">
               <a:rPr sz="1600" b="0" i="0">
                 <a:solidFill>
                   <a:srgbClr val="8A8A9A"/>
@@ -4654,7 +4654,7 @@
                 <a:latin typeface="Arial"/>
               </a:rPr>
               <a:t>14</a:t>
-            </a:r>
+            </a:fld>
           </a:p>
         </p:txBody>
       </p:sp>
@@ -4988,7 +4988,7 @@
           <a:lstStyle/>
           <a:p>
             <a:pPr algn="l"/>
-            <a:r>
+            <a:fld id="{4B0E1F8A-6C1D-4E2A-9F3B-7A5C8D2E1F60}" type="slidenum">
               <a:rPr sz="1600" b="0" i="0">
                 <a:solidFill>
                   <a:srgbClr val="8A8A9A"/>
@@ -4996,7 +4996,7 @@
                 <a:latin typeface="Arial"/>
               </a:rPr>
               <a:t>15</a:t>
-            </a:r>
+            </a:fld>
           </a:p>
         </p:txBody>
       </p:sp>
@@ -5225,7 +5225,7 @@
           <a:lstStyle/>
           <a:p>
             <a:pPr algn="l"/>
-            <a:r>
+            <a:fld id="{4B0E1F8A-6C1D-4E2A-9F3B-7A5C8D2E1F60}" type="slidenum">
               <a:rPr sz="1600" b="0" i="0">
                 <a:solidFill>
                   <a:srgbClr val="8A8A9A"/>
@@ -5233,7 +5233,7 @@
                 <a:latin typeface="Arial"/>
               </a:rPr>
               <a:t>16</a:t>
-            </a:r>
+            </a:fld>
           </a:p>
         </p:txBody>
       </p:sp>
@@ -5436,7 +5436,7 @@
           <a:lstStyle/>
           <a:p>
             <a:pPr algn="l"/>
-            <a:r>
+            <a:fld id="{4B0E1F8A-6C1D-4E2A-9F3B-7A5C8D2E1F60}" type="slidenum">
               <a:rPr sz="1600" b="0" i="0">
                 <a:solidFill>
                   <a:srgbClr val="8A8A9A"/>
@@ -5444,7 +5444,7 @@
                 <a:latin typeface="Arial"/>
               </a:rPr>
               <a:t>17</a:t>
-            </a:r>
+            </a:fld>
           </a:p>
         </p:txBody>
       </p:sp>
@@ -5847,7 +5847,7 @@
           <a:lstStyle/>
           <a:p>
             <a:pPr algn="l"/>
-            <a:r>
+            <a:fld id="{4B0E1F8A-6C1D-4E2A-9F3B-7A5C8D2E1F60}" type="slidenum">
               <a:rPr sz="1600" b="0" i="0">
                 <a:solidFill>
                   <a:srgbClr val="8A8A9A"/>
@@ -5855,7 +5855,7 @@
                 <a:latin typeface="Arial"/>
               </a:rPr>
               <a:t>18</a:t>
-            </a:r>
+            </a:fld>
           </a:p>
         </p:txBody>
       </p:sp>
@@ -6294,7 +6294,7 @@
           <a:lstStyle/>
           <a:p>
             <a:pPr algn="l"/>
-            <a:r>
+            <a:fld id="{4B0E1F8A-6C1D-4E2A-9F3B-7A5C8D2E1F60}" type="slidenum">
               <a:rPr sz="1600" b="0" i="0">
                 <a:solidFill>
                   <a:srgbClr val="8A8A9A"/>
@@ -6302,7 +6302,7 @@
                 <a:latin typeface="Arial"/>
               </a:rPr>
               <a:t>19</a:t>
-            </a:r>
+            </a:fld>
           </a:p>
         </p:txBody>
       </p:sp>
@@ -6505,7 +6505,7 @@
           <a:lstStyle/>
           <a:p>
             <a:pPr algn="l"/>
-            <a:r>
+            <a:fld id="{4B0E1F8A-6C1D-4E2A-9F3B-7A5C8D2E1F60}" type="slidenum">
               <a:rPr sz="1600" b="0" i="0">
                 <a:solidFill>
                   <a:srgbClr val="8A8A9A"/>
@@ -6513,7 +6513,7 @@
                 <a:latin typeface="Arial"/>
               </a:rPr>
               <a:t>2</a:t>
-            </a:r>
+            </a:fld>
           </a:p>
         </p:txBody>
       </p:sp>
@@ -6671,7 +6671,7 @@
           <a:lstStyle/>
           <a:p>
             <a:pPr algn="l"/>
-            <a:r>
+            <a:fld id="{4B0E1F8A-6C1D-4E2A-9F3B-7A5C8D2E1F60}" type="slidenum">
               <a:rPr sz="1600" b="0" i="0">
                 <a:solidFill>
                   <a:srgbClr val="8A8A9A"/>
@@ -6679,7 +6679,7 @@
                 <a:latin typeface="Arial"/>
               </a:rPr>
               <a:t>20</a:t>
-            </a:r>
+            </a:fld>
           </a:p>
         </p:txBody>
       </p:sp>
@@ -7355,7 +7355,7 @@
           <a:lstStyle/>
           <a:p>
             <a:pPr algn="l"/>
-            <a:r>
+            <a:fld id="{4B0E1F8A-6C1D-4E2A-9F3B-7A5C8D2E1F60}" type="slidenum">
               <a:rPr sz="1600" b="0" i="0">
                 <a:solidFill>
                   <a:srgbClr val="8A8A9A"/>
@@ -7363,7 +7363,7 @@
                 <a:latin typeface="Arial"/>
               </a:rPr>
               <a:t>21</a:t>
-            </a:r>
+            </a:fld>
           </a:p>
         </p:txBody>
       </p:sp>
@@ -7530,7 +7530,7 @@
           <a:lstStyle/>
           <a:p>
             <a:pPr algn="l"/>
-            <a:r>
+            <a:fld id="{4B0E1F8A-6C1D-4E2A-9F3B-7A5C8D2E1F60}" type="slidenum">
               <a:rPr sz="1600" b="0" i="0">
                 <a:solidFill>
                   <a:srgbClr val="8A8A9A"/>
@@ -7538,7 +7538,7 @@
                 <a:latin typeface="Arial"/>
               </a:rPr>
               <a:t>22</a:t>
-            </a:r>
+            </a:fld>
           </a:p>
         </p:txBody>
       </p:sp>
@@ -7705,7 +7705,7 @@
           <a:lstStyle/>
           <a:p>
             <a:pPr algn="l"/>
-            <a:r>
+            <a:fld id="{4B0E1F8A-6C1D-4E2A-9F3B-7A5C8D2E1F60}" type="slidenum">
               <a:rPr sz="1600" b="0" i="0">
                 <a:solidFill>
                   <a:srgbClr val="8A8A9A"/>
@@ -7713,7 +7713,7 @@
                 <a:latin typeface="Arial"/>
               </a:rPr>
               <a:t>23</a:t>
-            </a:r>
+            </a:fld>
           </a:p>
         </p:txBody>
       </p:sp>
@@ -7942,7 +7942,7 @@
           <a:lstStyle/>
           <a:p>
             <a:pPr algn="l"/>
-            <a:r>
+            <a:fld id="{4B0E1F8A-6C1D-4E2A-9F3B-7A5C8D2E1F60}" type="slidenum">
               <a:rPr sz="1600" b="0" i="0">
                 <a:solidFill>
                   <a:srgbClr val="8A8A9A"/>
@@ -7950,7 +7950,7 @@
                 <a:latin typeface="Arial"/>
               </a:rPr>
               <a:t>24</a:t>
-            </a:r>
+            </a:fld>
           </a:p>
         </p:txBody>
       </p:sp>
@@ -8442,7 +8442,7 @@
           <a:lstStyle/>
           <a:p>
             <a:pPr algn="l"/>
-            <a:r>
+            <a:fld id="{4B0E1F8A-6C1D-4E2A-9F3B-7A5C8D2E1F60}" type="slidenum">
               <a:rPr sz="1600" b="0" i="0">
                 <a:solidFill>
                   <a:srgbClr val="8A8A9A"/>
@@ -8450,7 +8450,7 @@
                 <a:latin typeface="Arial"/>
               </a:rPr>
               <a:t>25</a:t>
-            </a:r>
+            </a:fld>
           </a:p>
         </p:txBody>
       </p:sp>
@@ -8968,7 +8968,7 @@
           <a:lstStyle/>
           <a:p>
             <a:pPr algn="l"/>
-            <a:r>
+            <a:fld id="{4B0E1F8A-6C1D-4E2A-9F3B-7A5C8D2E1F60}" type="slidenum">
               <a:rPr sz="1600" b="0" i="0">
                 <a:solidFill>
                   <a:srgbClr val="8A8A9A"/>
@@ -8976,7 +8976,7 @@
                 <a:latin typeface="Arial"/>
               </a:rPr>
               <a:t>26</a:t>
-            </a:r>
+            </a:fld>
           </a:p>
         </p:txBody>
       </p:sp>
@@ -9179,7 +9179,7 @@
           <a:lstStyle/>
           <a:p>
             <a:pPr algn="l"/>
-            <a:r>
+            <a:fld id="{4B0E1F8A-6C1D-4E2A-9F3B-7A5C8D2E1F60}" type="slidenum">
               <a:rPr sz="1600" b="0" i="0">
                 <a:solidFill>
                   <a:srgbClr val="8A8A9A"/>
@@ -9187,7 +9187,7 @@
                 <a:latin typeface="Arial"/>
               </a:rPr>
               <a:t>27</a:t>
-            </a:r>
+            </a:fld>
           </a:p>
         </p:txBody>
       </p:sp>
@@ -9354,7 +9354,7 @@
           <a:lstStyle/>
           <a:p>
             <a:pPr algn="l"/>
-            <a:r>
+            <a:fld id="{4B0E1F8A-6C1D-4E2A-9F3B-7A5C8D2E1F60}" type="slidenum">
               <a:rPr sz="1600" b="0" i="0">
                 <a:solidFill>
                   <a:srgbClr val="8A8A9A"/>
@@ -9362,7 +9362,7 @@
                 <a:latin typeface="Arial"/>
               </a:rPr>
               <a:t>28</a:t>
-            </a:r>
+            </a:fld>
           </a:p>
         </p:txBody>
       </p:sp>
@@ -9591,7 +9591,7 @@
           <a:lstStyle/>
           <a:p>
             <a:pPr algn="l"/>
-            <a:r>
+            <a:fld id="{4B0E1F8A-6C1D-4E2A-9F3B-7A5C8D2E1F60}" type="slidenum">
               <a:rPr sz="1600" b="0" i="0">
                 <a:solidFill>
                   <a:srgbClr val="8A8A9A"/>
@@ -9599,7 +9599,7 @@
                 <a:latin typeface="Arial"/>
               </a:rPr>
               <a:t>29</a:t>
-            </a:r>
+            </a:fld>
           </a:p>
         </p:txBody>
       </p:sp>
@@ -9898,7 +9898,7 @@
           <a:lstStyle/>
           <a:p>
             <a:pPr algn="l"/>
-            <a:r>
+            <a:fld id="{4B0E1F8A-6C1D-4E2A-9F3B-7A5C8D2E1F60}" type="slidenum">
               <a:rPr sz="1600" b="0" i="0">
                 <a:solidFill>
                   <a:srgbClr val="8A8A9A"/>
@@ -9906,7 +9906,7 @@
                 <a:latin typeface="Arial"/>
               </a:rPr>
               <a:t>3</a:t>
-            </a:r>
+            </a:fld>
           </a:p>
         </p:txBody>
       </p:sp>
@@ -10344,7 +10344,7 @@
           <a:lstStyle/>
           <a:p>
             <a:pPr algn="l"/>
-            <a:r>
+            <a:fld id="{4B0E1F8A-6C1D-4E2A-9F3B-7A5C8D2E1F60}" type="slidenum">
               <a:rPr sz="1600" b="0" i="0">
                 <a:solidFill>
                   <a:srgbClr val="8A8A9A"/>
@@ -10352,7 +10352,7 @@
                 <a:latin typeface="Arial"/>
               </a:rPr>
               <a:t>30</a:t>
-            </a:r>
+            </a:fld>
           </a:p>
         </p:txBody>
       </p:sp>
@@ -10580,7 +10580,7 @@
           <a:lstStyle/>
           <a:p>
             <a:pPr algn="l"/>
-            <a:r>
+            <a:fld id="{4B0E1F8A-6C1D-4E2A-9F3B-7A5C8D2E1F60}" type="slidenum">
               <a:rPr sz="1600" b="0" i="0">
                 <a:solidFill>
                   <a:srgbClr val="8A8A9A"/>
@@ -10588,7 +10588,7 @@
                 <a:latin typeface="Arial"/>
               </a:rPr>
               <a:t>31</a:t>
-            </a:r>
+            </a:fld>
           </a:p>
         </p:txBody>
       </p:sp>
@@ -10791,7 +10791,7 @@
           <a:lstStyle/>
           <a:p>
             <a:pPr algn="l"/>
-            <a:r>
+            <a:fld id="{4B0E1F8A-6C1D-4E2A-9F3B-7A5C8D2E1F60}" type="slidenum">
               <a:rPr sz="1600" b="0" i="0">
                 <a:solidFill>
                   <a:srgbClr val="8A8A9A"/>
@@ -10799,7 +10799,7 @@
                 <a:latin typeface="Arial"/>
               </a:rPr>
               <a:t>32</a:t>
-            </a:r>
+            </a:fld>
           </a:p>
         </p:txBody>
       </p:sp>
@@ -11291,7 +11291,7 @@
           <a:lstStyle/>
           <a:p>
             <a:pPr algn="l"/>
-            <a:r>
+            <a:fld id="{4B0E1F8A-6C1D-4E2A-9F3B-7A5C8D2E1F60}" type="slidenum">
               <a:rPr sz="1600" b="0" i="0">
                 <a:solidFill>
                   <a:srgbClr val="8A8A9A"/>
@@ -11299,7 +11299,7 @@
                 <a:latin typeface="Arial"/>
               </a:rPr>
               <a:t>33</a:t>
-            </a:r>
+            </a:fld>
           </a:p>
         </p:txBody>
       </p:sp>
@@ -11502,7 +11502,7 @@
           <a:lstStyle/>
           <a:p>
             <a:pPr algn="l"/>
-            <a:r>
+            <a:fld id="{4B0E1F8A-6C1D-4E2A-9F3B-7A5C8D2E1F60}" type="slidenum">
               <a:rPr sz="1600" b="0" i="0">
                 <a:solidFill>
                   <a:srgbClr val="8A8A9A"/>
@@ -11510,7 +11510,7 @@
                 <a:latin typeface="Arial"/>
               </a:rPr>
               <a:t>34</a:t>
-            </a:r>
+            </a:fld>
           </a:p>
         </p:txBody>
       </p:sp>
@@ -11677,7 +11677,7 @@
           <a:lstStyle/>
           <a:p>
             <a:pPr algn="l"/>
-            <a:r>
+            <a:fld id="{4B0E1F8A-6C1D-4E2A-9F3B-7A5C8D2E1F60}" type="slidenum">
               <a:rPr sz="1600" b="0" i="0">
                 <a:solidFill>
                   <a:srgbClr val="8A8A9A"/>
@@ -11685,7 +11685,7 @@
                 <a:latin typeface="Arial"/>
               </a:rPr>
               <a:t>35</a:t>
-            </a:r>
+            </a:fld>
           </a:p>
         </p:txBody>
       </p:sp>
@@ -11914,7 +11914,7 @@
           <a:lstStyle/>
           <a:p>
             <a:pPr algn="l"/>
-            <a:r>
+            <a:fld id="{4B0E1F8A-6C1D-4E2A-9F3B-7A5C8D2E1F60}" type="slidenum">
               <a:rPr sz="1600" b="0" i="0">
                 <a:solidFill>
                   <a:srgbClr val="8A8A9A"/>
@@ -11922,7 +11922,7 @@
                 <a:latin typeface="Arial"/>
               </a:rPr>
               <a:t>36</a:t>
-            </a:r>
+            </a:fld>
           </a:p>
         </p:txBody>
       </p:sp>
@@ -12125,7 +12125,7 @@
           <a:lstStyle/>
           <a:p>
             <a:pPr algn="l"/>
-            <a:r>
+            <a:fld id="{4B0E1F8A-6C1D-4E2A-9F3B-7A5C8D2E1F60}" type="slidenum">
               <a:rPr sz="1600" b="0" i="0">
                 <a:solidFill>
                   <a:srgbClr val="8A8A9A"/>
@@ -12133,7 +12133,7 @@
                 <a:latin typeface="Arial"/>
               </a:rPr>
               <a:t>37</a:t>
-            </a:r>
+            </a:fld>
           </a:p>
         </p:txBody>
       </p:sp>
@@ -12625,7 +12625,7 @@
           <a:lstStyle/>
           <a:p>
             <a:pPr algn="l"/>
-            <a:r>
+            <a:fld id="{4B0E1F8A-6C1D-4E2A-9F3B-7A5C8D2E1F60}" type="slidenum">
               <a:rPr sz="1600" b="0" i="0">
                 <a:solidFill>
                   <a:srgbClr val="8A8A9A"/>
@@ -12633,7 +12633,7 @@
                 <a:latin typeface="Arial"/>
               </a:rPr>
               <a:t>38</a:t>
-            </a:r>
+            </a:fld>
           </a:p>
         </p:txBody>
       </p:sp>
@@ -12801,7 +12801,7 @@
           <a:lstStyle/>
           <a:p>
             <a:pPr algn="l"/>
-            <a:r>
+            <a:fld id="{4B0E1F8A-6C1D-4E2A-9F3B-7A5C8D2E1F60}" type="slidenum">
               <a:rPr sz="1600" b="0" i="0">
                 <a:solidFill>
                   <a:srgbClr val="8A8A9A"/>
@@ -12809,7 +12809,7 @@
                 <a:latin typeface="Arial"/>
               </a:rPr>
               <a:t>39</a:t>
-            </a:r>
+            </a:fld>
           </a:p>
         </p:txBody>
       </p:sp>
@@ -13107,7 +13107,7 @@
           <a:lstStyle/>
           <a:p>
             <a:pPr algn="l"/>
-            <a:r>
+            <a:fld id="{4B0E1F8A-6C1D-4E2A-9F3B-7A5C8D2E1F60}" type="slidenum">
               <a:rPr sz="1600" b="0" i="0">
                 <a:solidFill>
                   <a:srgbClr val="8A8A9A"/>
@@ -13115,7 +13115,7 @@
                 <a:latin typeface="Arial"/>
               </a:rPr>
               <a:t>4</a:t>
-            </a:r>
+            </a:fld>
           </a:p>
         </p:txBody>
       </p:sp>
@@ -13720,7 +13720,7 @@
           <a:lstStyle/>
           <a:p>
             <a:pPr algn="l"/>
-            <a:r>
+            <a:fld id="{4B0E1F8A-6C1D-4E2A-9F3B-7A5C8D2E1F60}" type="slidenum">
               <a:rPr sz="1600" b="0" i="0">
                 <a:solidFill>
                   <a:srgbClr val="8A8A9A"/>
@@ -13728,7 +13728,7 @@
                 <a:latin typeface="Arial"/>
               </a:rPr>
               <a:t>5</a:t>
-            </a:r>
+            </a:fld>
           </a:p>
         </p:txBody>
       </p:sp>
@@ -14096,7 +14096,7 @@
           <a:lstStyle/>
           <a:p>
             <a:pPr algn="l"/>
-            <a:r>
+            <a:fld id="{4B0E1F8A-6C1D-4E2A-9F3B-7A5C8D2E1F60}" type="slidenum">
               <a:rPr sz="1600" b="0" i="0">
                 <a:solidFill>
                   <a:srgbClr val="8A8A9A"/>
@@ -14104,7 +14104,7 @@
                 <a:latin typeface="Arial"/>
               </a:rPr>
               <a:t>6</a:t>
-            </a:r>
+            </a:fld>
           </a:p>
         </p:txBody>
       </p:sp>
@@ -14788,7 +14788,7 @@
           <a:lstStyle/>
           <a:p>
             <a:pPr algn="l"/>
-            <a:r>
+            <a:fld id="{4B0E1F8A-6C1D-4E2A-9F3B-7A5C8D2E1F60}" type="slidenum">
               <a:rPr sz="1600" b="0" i="0">
                 <a:solidFill>
                   <a:srgbClr val="8A8A9A"/>
@@ -14796,7 +14796,7 @@
                 <a:latin typeface="Arial"/>
               </a:rPr>
               <a:t>7</a:t>
-            </a:r>
+            </a:fld>
           </a:p>
         </p:txBody>
       </p:sp>
@@ -15252,7 +15252,7 @@
           <a:lstStyle/>
           <a:p>
             <a:pPr algn="l"/>
-            <a:r>
+            <a:fld id="{4B0E1F8A-6C1D-4E2A-9F3B-7A5C8D2E1F60}" type="slidenum">
               <a:rPr sz="1600" b="0" i="0">
                 <a:solidFill>
                   <a:srgbClr val="8A8A9A"/>
@@ -15260,7 +15260,7 @@
                 <a:latin typeface="Arial"/>
               </a:rPr>
               <a:t>8</a:t>
-            </a:r>
+            </a:fld>
           </a:p>
         </p:txBody>
       </p:sp>
@@ -15742,7 +15742,7 @@
           <a:lstStyle/>
           <a:p>
             <a:pPr algn="l"/>
-            <a:r>
+            <a:fld id="{4B0E1F8A-6C1D-4E2A-9F3B-7A5C8D2E1F60}" type="slidenum">
               <a:rPr sz="1600" b="0" i="0">
                 <a:solidFill>
                   <a:srgbClr val="8A8A9A"/>
@@ -15750,7 +15750,7 @@
                 <a:latin typeface="Arial"/>
               </a:rPr>
               <a:t>9</a:t>
-            </a:r>
+            </a:fld>
           </a:p>
         </p:txBody>
       </p:sp>

</xml_diff>